<commit_message>
docs: fill presentation with project content
Co-Authored-By: Claude Opus 5.5 <noreply@anthropic.com>
</commit_message>
<xml_diff>
--- a/05. DOCUMENTACION/PRESENTACION TI.1.1. SOAP sin BDD en JAVA GR4.pptx
+++ b/05. DOCUMENTACION/PRESENTACION TI.1.1. SOAP sin BDD en JAVA GR4.pptx
@@ -8402,7 +8402,7 @@
           <a:p>
             <a:r>
               <a:rPr lang="es-EC"/>
-              <a:t>Servidor [SOAP | RESTful]</a:t>
+              <a:t>Servidor SOAP</a:t>
             </a:r>
           </a:p>
         </p:txBody>
@@ -8458,7 +8458,7 @@
           <a:p>
             <a:r>
               <a:rPr lang="es-MX"/>
-              <a:t>[Tecnología] · [URL base del servicio]</a:t>
+              <a:t>Jakarta EE en Payara (JAX-WS) · http://localhost:8080/WS_CON_UNI_JAVA_SOAP/</a:t>
             </a:r>
             <a:endParaRPr lang="es-EC"/>
           </a:p>
@@ -8549,7 +8549,7 @@
             </a:pPr>
             <a:r>
               <a:rPr lang="es-MX"/>
-              <a:t>Crear un proyecto [tipo de proyecto] en [IDE].</a:t>
+              <a:t>Crear un proyecto Java with Maven › Web Application en NetBeans 31.</a:t>
             </a:r>
           </a:p>
           <a:p>
@@ -8559,7 +8559,7 @@
             </a:pPr>
             <a:r>
               <a:rPr lang="es-MX"/>
-              <a:t>Nombrarlo WS_CON_UNI_[JAVA | DOTNET]_[SOAP | RESTful] con el paquete ec.edu.monster.</a:t>
+              <a:t>Nombrarlo WS_CON_UNI_JAVA_SOAP con el paquete ec.edu.monster.</a:t>
             </a:r>
           </a:p>
           <a:p>
@@ -8569,7 +8569,7 @@
             </a:pPr>
             <a:r>
               <a:rPr lang="es-MX"/>
-              <a:t>Configurar [servidor de aplicaciones y puerto].</a:t>
+              <a:t>Configurar Payara Server en el puerto 8080.</a:t>
             </a:r>
           </a:p>
           <a:p>
@@ -8579,7 +8579,7 @@
             </a:pPr>
             <a:r>
               <a:rPr lang="es-MX"/>
-              <a:t>Agregar las dependencias: [librerías].</a:t>
+              <a:t>Agregar las dependencias: jakarta.jakartaee-api 11 y webservices-rt 4.0.6.</a:t>
             </a:r>
             <a:endParaRPr lang="es-EC"/>
           </a:p>
@@ -8762,7 +8762,7 @@
           <a:p>
             <a:r>
               <a:rPr lang="es-MX"/>
-              <a:t>[Servicios web SOAP | Endpoints REST]: exponen las operaciones al exterior.</a:t>
+              <a:t>Servicios web SOAP (LoginWebService y ConversorWebService): exponen las operaciones al exterior.</a:t>
             </a:r>
             <a:endParaRPr lang="es-EC"/>
           </a:p>
@@ -9607,7 +9607,7 @@
                 </a:solidFill>
                 <a:latin typeface="Segoe UI" panose="020B0502040204020203" pitchFamily="34" charset="0"/>
               </a:rPr>
-              <a:t>Rutas en este proyecto:  [login → …]  ·  [catálogo → …]  ·  [conversión → …]</a:t>
+              <a:t>Rutas en este proyecto:  login → LoginWebService.login  ·  catálogo → ConversorWebService.catalog  ·  conversión → ConversorWebService.convert</a:t>
             </a:r>
             <a:endParaRPr lang="es-EC" sz="1500">
               <a:solidFill>
@@ -10837,58 +10837,324 @@
           <a:p>
             <a:pPr>
               <a:lnSpc>
-                <a:spcPct val="110000"/>
+                <a:spcPct val="100000"/>
               </a:lnSpc>
+              <a:spcBef>
+                <a:spcPts val="0"/>
+              </a:spcBef>
+              <a:spcAft>
+                <a:spcPts val="0"/>
+              </a:spcAft>
             </a:pPr>
             <a:r>
-              <a:rPr lang="es-MX"/>
-              <a:t>[Pega aquí el fragmento principal:</a:t>
+              <a:rPr lang="en-US" noProof="1"/>
+              <a:t xml:space="preserve">@WebService(serviceName = "ConversorWebService")</a:t>
             </a:r>
           </a:p>
           <a:p>
             <a:pPr>
               <a:lnSpc>
-                <a:spcPct val="110000"/>
+                <a:spcPct val="100000"/>
               </a:lnSpc>
+              <a:spcBef>
+                <a:spcPts val="0"/>
+              </a:spcBef>
+              <a:spcAft>
+                <a:spcPts val="0"/>
+              </a:spcAft>
             </a:pPr>
             <a:r>
+              <a:rPr lang="en-US" noProof="1"/>
+              <a:t xml:space="preserve">public class ConversorWebService {</a:t>
+            </a:r>
+          </a:p>
+          <a:p>
+            <a:pPr>
+              <a:lnSpc>
+                <a:spcPct val="100000"/>
+              </a:lnSpc>
+              <a:spcBef>
+                <a:spcPts val="0"/>
+              </a:spcBef>
+              <a:spcAft>
+                <a:spcPts val="0"/>
+              </a:spcAft>
+            </a:pPr>
+            <a:r>
+              <a:rPr lang="en-US" noProof="1"/>
+              <a:t xml:space="preserve">  @WebMethod(operationName = "convert")</a:t>
+            </a:r>
+          </a:p>
+          <a:p>
+            <a:pPr>
+              <a:lnSpc>
+                <a:spcPct val="100000"/>
+              </a:lnSpc>
+              <a:spcBef>
+                <a:spcPts val="0"/>
+              </a:spcBef>
+              <a:spcAft>
+                <a:spcPts val="0"/>
+              </a:spcAft>
+            </a:pPr>
+            <a:r>
+              <a:rPr lang="en-US" noProof="1"/>
+              <a:t xml:space="preserve">  public ConverterDTO convert(</a:t>
+            </a:r>
+          </a:p>
+          <a:p>
+            <a:pPr>
+              <a:lnSpc>
+                <a:spcPct val="100000"/>
+              </a:lnSpc>
+              <a:spcBef>
+                <a:spcPts val="0"/>
+              </a:spcBef>
+              <a:spcAft>
+                <a:spcPts val="0"/>
+              </a:spcAft>
+            </a:pPr>
+            <a:r>
+              <a:rPr lang="en-US" noProof="1"/>
+              <a:t xml:space="preserve">      @WebParam(name = "token") String token,</a:t>
+            </a:r>
+          </a:p>
+          <a:p>
+            <a:pPr>
+              <a:lnSpc>
+                <a:spcPct val="100000"/>
+              </a:lnSpc>
+              <a:spcBef>
+                <a:spcPts val="0"/>
+              </a:spcBef>
+              <a:spcAft>
+                <a:spcPts val="0"/>
+              </a:spcAft>
+            </a:pPr>
+            <a:r>
+              <a:rPr lang="en-US" noProof="1"/>
+              <a:t xml:space="preserve">      @WebParam(name = "type") String type,</a:t>
+            </a:r>
+          </a:p>
+          <a:p>
+            <a:pPr>
+              <a:lnSpc>
+                <a:spcPct val="100000"/>
+              </a:lnSpc>
+              <a:spcBef>
+                <a:spcPts val="0"/>
+              </a:spcBef>
+              <a:spcAft>
+                <a:spcPts val="0"/>
+              </a:spcAft>
+            </a:pPr>
+            <a:r>
+              <a:rPr lang="en-US" noProof="1"/>
+              <a:t xml:space="preserve">      @WebParam(name = "value") double value,</a:t>
+            </a:r>
+          </a:p>
+          <a:p>
+            <a:pPr>
+              <a:lnSpc>
+                <a:spcPct val="100000"/>
+              </a:lnSpc>
+              <a:spcBef>
+                <a:spcPts val="0"/>
+              </a:spcBef>
+              <a:spcAft>
+                <a:spcPts val="0"/>
+              </a:spcAft>
+            </a:pPr>
+            <a:r>
+              <a:rPr lang="en-US" noProof="1"/>
+              <a:t xml:space="preserve">      @WebParam(name = "from") String from,</a:t>
+            </a:r>
+          </a:p>
+          <a:p>
+            <a:pPr>
+              <a:lnSpc>
+                <a:spcPct val="100000"/>
+              </a:lnSpc>
+              <a:spcBef>
+                <a:spcPts val="0"/>
+              </a:spcBef>
+              <a:spcAft>
+                <a:spcPts val="0"/>
+              </a:spcAft>
+            </a:pPr>
+            <a:r>
+              <a:rPr lang="en-US" noProof="1"/>
+              <a:t xml:space="preserve">      @WebParam(name = "to") String to) {</a:t>
+            </a:r>
+          </a:p>
+          <a:p>
+            <a:pPr>
+              <a:lnSpc>
+                <a:spcPct val="100000"/>
+              </a:lnSpc>
+              <a:spcBef>
+                <a:spcPts val="0"/>
+              </a:spcBef>
+              <a:spcAft>
+                <a:spcPts val="0"/>
+              </a:spcAft>
+            </a:pPr>
+            <a:r>
+              <a:rPr lang="en-US" noProof="1"/>
+              <a:t xml:space="preserve">    if (!LoginController.validateUser(token))</a:t>
+            </a:r>
+          </a:p>
+          <a:p>
+            <a:pPr>
+              <a:lnSpc>
+                <a:spcPct val="100000"/>
+              </a:lnSpc>
+              <a:spcBef>
+                <a:spcPts val="0"/>
+              </a:spcBef>
+              <a:spcAft>
+                <a:spcPts val="0"/>
+              </a:spcAft>
+            </a:pPr>
+            <a:r>
+              <a:rPr lang="en-US" noProof="1"/>
+              <a:t xml:space="preserve">      return new ConverterDTO(EstadosEnum.ERROR,</a:t>
+            </a:r>
+          </a:p>
+          <a:p>
+            <a:pPr>
+              <a:lnSpc>
+                <a:spcPct val="100000"/>
+              </a:lnSpc>
+              <a:spcBef>
+                <a:spcPts val="0"/>
+              </a:spcBef>
+              <a:spcAft>
+                <a:spcPts val="0"/>
+              </a:spcAft>
+            </a:pPr>
+            <a:r>
+              <a:rPr lang="en-US" noProof="1"/>
+              <a:t xml:space="preserve">          "Invalid Token", 0);</a:t>
+            </a:r>
+          </a:p>
+          <a:p>
+            <a:pPr>
+              <a:lnSpc>
+                <a:spcPct val="100000"/>
+              </a:lnSpc>
+              <a:spcBef>
+                <a:spcPts val="0"/>
+              </a:spcBef>
+              <a:spcAft>
+                <a:spcPts val="0"/>
+              </a:spcAft>
+            </a:pPr>
+            <a:r>
+              <a:rPr lang="en-US" noProof="1"/>
+              <a:t xml:space="preserve">    return new ConverterDTO(EstadosEnum.OK,</a:t>
+            </a:r>
+          </a:p>
+          <a:p>
+            <a:pPr>
+              <a:lnSpc>
+                <a:spcPct val="100000"/>
+              </a:lnSpc>
+              <a:spcBef>
+                <a:spcPts val="0"/>
+              </a:spcBef>
+              <a:spcAft>
+                <a:spcPts val="0"/>
+              </a:spcAft>
+            </a:pPr>
+            <a:r>
+              <a:rPr lang="en-US" noProof="1"/>
+              <a:t xml:space="preserve">        "Conversión Exitosa",</a:t>
+            </a:r>
+          </a:p>
+          <a:p>
+            <a:pPr>
+              <a:lnSpc>
+                <a:spcPct val="100000"/>
+              </a:lnSpc>
+              <a:spcBef>
+                <a:spcPts val="0"/>
+              </a:spcBef>
+              <a:spcAft>
+                <a:spcPts val="0"/>
+              </a:spcAft>
+            </a:pPr>
+            <a:r>
+              <a:rPr lang="en-US" noProof="1"/>
+              <a:t xml:space="preserve">        ConverterController.convert(type, value, from, to));</a:t>
+            </a:r>
+          </a:p>
+          <a:p>
+            <a:pPr>
+              <a:lnSpc>
+                <a:spcPct val="100000"/>
+              </a:lnSpc>
+              <a:spcBef>
+                <a:spcPts val="0"/>
+              </a:spcBef>
+              <a:spcAft>
+                <a:spcPts val="0"/>
+              </a:spcAft>
+            </a:pPr>
+            <a:r>
+              <a:rPr lang="en-US" noProof="1"/>
+              <a:t xml:space="preserve">  }</a:t>
+            </a:r>
+          </a:p>
+          <a:p>
+            <a:pPr>
+              <a:lnSpc>
+                <a:spcPct val="100000"/>
+              </a:lnSpc>
+              <a:spcBef>
+                <a:spcPts val="0"/>
+              </a:spcBef>
+              <a:spcAft>
+                <a:spcPts val="0"/>
+              </a:spcAft>
+            </a:pPr>
+            <a:r>
+              <a:rPr lang="en-US" noProof="1"/>
+              <a:t xml:space="preserve">}</a:t>
+            </a:r>
+          </a:p>
+        </p:txBody>
+      </p:sp>
+      <p:sp>
+        <p:nvSpPr>
+          <p:cNvPr id="4" name="Text Placeholder 3">
+            <a:extLst>
+              <a:ext uri="{FF2B5EF4-FFF2-40B4-BE49-F238E27FC236}">
+                <a16:creationId xmlns:a16="http://schemas.microsoft.com/office/drawing/2014/main" id="{0B26EB7F-8CAF-5D1F-5E05-124982840E83}"/>
+              </a:ext>
+            </a:extLst>
+          </p:cNvPr>
+          <p:cNvSpPr>
+            <a:spLocks noGrp="1"/>
+          </p:cNvSpPr>
+          <p:nvPr>
+            <p:ph type="body" sz="quarter" idx="12"/>
+          </p:nvPr>
+        </p:nvSpPr>
+        <p:spPr/>
+        <p:txBody>
+          <a:bodyPr/>
+          <a:lstStyle/>
+          <a:p>
+            <a:r>
               <a:rPr lang="es-MX"/>
-              <a:t> definición del servicio o endpoint]</a:t>
-            </a:r>
-            <a:endParaRPr lang="es-EC"/>
-          </a:p>
-        </p:txBody>
-      </p:sp>
-      <p:sp>
-        <p:nvSpPr>
-          <p:cNvPr id="4" name="Text Placeholder 3">
-            <a:extLst>
-              <a:ext uri="{FF2B5EF4-FFF2-40B4-BE49-F238E27FC236}">
-                <a16:creationId xmlns:a16="http://schemas.microsoft.com/office/drawing/2014/main" id="{0B26EB7F-8CAF-5D1F-5E05-124982840E83}"/>
-              </a:ext>
-            </a:extLst>
-          </p:cNvPr>
-          <p:cNvSpPr>
-            <a:spLocks noGrp="1"/>
-          </p:cNvSpPr>
-          <p:nvPr>
-            <p:ph type="body" sz="quarter" idx="12"/>
-          </p:nvPr>
-        </p:nvSpPr>
-        <p:spPr/>
-        <p:txBody>
-          <a:bodyPr/>
-          <a:lstStyle/>
+              <a:t>@WebService y @WebMethod publican la clase como servicio SOAP; Payara genera el WSDL automáticamente.</a:t>
+            </a:r>
+          </a:p>
           <a:p>
             <a:r>
               <a:rPr lang="es-MX"/>
-              <a:t>[Qué hace este fragmento.]</a:t>
-            </a:r>
-          </a:p>
-          <a:p>
-            <a:r>
-              <a:rPr lang="es-MX"/>
-              <a:t>[Por qué es importante en el proyecto.]</a:t>
+              <a:t>Cada operación valida el token antes de convertir, así nadie usa el servicio sin iniciar sesión.</a:t>
             </a:r>
             <a:endParaRPr lang="es-EC"/>
           </a:p>
@@ -11035,13 +11301,13 @@
           <a:p>
             <a:r>
               <a:rPr lang="es-MX"/>
-              <a:t>Ejecutar el servidor desde [IDE o comando].</a:t>
+              <a:t>Ejecutar el servidor desde NetBeans 31 (Run) sobre Payara Server.</a:t>
             </a:r>
           </a:p>
           <a:p>
             <a:r>
               <a:rPr lang="es-MX"/>
-              <a:t>Comprobar [el WSDL en … | el endpoint en …].</a:t>
+              <a:t>Comprobar el WSDL en http://localhost:8080/WS_CON_UNI_JAVA_SOAP/LoginWebService?wsdl.</a:t>
             </a:r>
           </a:p>
           <a:p>
@@ -11240,7 +11506,7 @@
           <a:p>
             <a:r>
               <a:rPr lang="es-EC"/>
-              <a:t>[Tecnología] · patrón MVC</a:t>
+              <a:t>Java 21 + Apache CXF · patrón MVC</a:t>
             </a:r>
           </a:p>
         </p:txBody>
@@ -11327,7 +11593,7 @@
           <a:p>
             <a:r>
               <a:rPr lang="es-MX"/>
-              <a:t>Proyecto CONSOLE_CON_UNI_[JAVA | DOTNET]_[SOAP | RESTful] creado en [IDE].</a:t>
+              <a:t>Proyecto CONSOLE_CON_UNI_JAVA_SOAP creado en NetBeans 31.</a:t>
             </a:r>
           </a:p>
           <a:p>
@@ -11510,58 +11776,202 @@
           <a:p>
             <a:pPr>
               <a:lnSpc>
-                <a:spcPct val="110000"/>
+                <a:spcPct val="100000"/>
               </a:lnSpc>
+              <a:spcBef>
+                <a:spcPts val="0"/>
+              </a:spcBef>
+              <a:spcAft>
+                <a:spcPts val="0"/>
+              </a:spcAft>
             </a:pPr>
             <a:r>
-              <a:rPr lang="es-MX"/>
-              <a:t>[Pega aquí cómo el cliente</a:t>
+              <a:rPr lang="en-US" noProof="1"/>
+              <a:t xml:space="preserve">public class LoginHTTP {</a:t>
             </a:r>
           </a:p>
           <a:p>
             <a:pPr>
               <a:lnSpc>
-                <a:spcPct val="110000"/>
+                <a:spcPct val="100000"/>
               </a:lnSpc>
+              <a:spcBef>
+                <a:spcPts val="0"/>
+              </a:spcBef>
+              <a:spcAft>
+                <a:spcPts val="0"/>
+              </a:spcAft>
             </a:pPr>
             <a:r>
+              <a:rPr lang="en-US" noProof="1"/>
+              <a:t xml:space="preserve">  private LoginWebService_Service service =</a:t>
+            </a:r>
+          </a:p>
+          <a:p>
+            <a:pPr>
+              <a:lnSpc>
+                <a:spcPct val="100000"/>
+              </a:lnSpc>
+              <a:spcBef>
+                <a:spcPts val="0"/>
+              </a:spcBef>
+              <a:spcAft>
+                <a:spcPts val="0"/>
+              </a:spcAft>
+            </a:pPr>
+            <a:r>
+              <a:rPr lang="en-US" noProof="1"/>
+              <a:t xml:space="preserve">      new LoginWebService_Service();</a:t>
+            </a:r>
+          </a:p>
+          <a:p>
+            <a:pPr>
+              <a:lnSpc>
+                <a:spcPct val="100000"/>
+              </a:lnSpc>
+              <a:spcBef>
+                <a:spcPts val="0"/>
+              </a:spcBef>
+              <a:spcAft>
+                <a:spcPts val="0"/>
+              </a:spcAft>
+            </a:pPr>
+            <a:r>
+              <a:rPr lang="en-US" noProof="1"/>
+              <a:t xml:space="preserve">  private LoginWebService port =</a:t>
+            </a:r>
+          </a:p>
+          <a:p>
+            <a:pPr>
+              <a:lnSpc>
+                <a:spcPct val="100000"/>
+              </a:lnSpc>
+              <a:spcBef>
+                <a:spcPts val="0"/>
+              </a:spcBef>
+              <a:spcAft>
+                <a:spcPts val="0"/>
+              </a:spcAft>
+            </a:pPr>
+            <a:r>
+              <a:rPr lang="en-US" noProof="1"/>
+              <a:t xml:space="preserve">      service.getLoginWebServicePort();</a:t>
+            </a:r>
+          </a:p>
+          <a:p>
+            <a:pPr>
+              <a:lnSpc>
+                <a:spcPct val="100000"/>
+              </a:lnSpc>
+              <a:spcBef>
+                <a:spcPts val="0"/>
+              </a:spcBef>
+              <a:spcAft>
+                <a:spcPts val="0"/>
+              </a:spcAft>
+            </a:pPr>
+            <a:endParaRPr lang="en-US" noProof="1"/>
+          </a:p>
+          <a:p>
+            <a:pPr>
+              <a:lnSpc>
+                <a:spcPct val="100000"/>
+              </a:lnSpc>
+              <a:spcBef>
+                <a:spcPts val="0"/>
+              </a:spcBef>
+              <a:spcAft>
+                <a:spcPts val="0"/>
+              </a:spcAft>
+            </a:pPr>
+            <a:r>
+              <a:rPr lang="en-US" noProof="1"/>
+              <a:t xml:space="preserve">  public LoginDTO login(String username, String password) {</a:t>
+            </a:r>
+          </a:p>
+          <a:p>
+            <a:pPr>
+              <a:lnSpc>
+                <a:spcPct val="100000"/>
+              </a:lnSpc>
+              <a:spcBef>
+                <a:spcPts val="0"/>
+              </a:spcBef>
+              <a:spcAft>
+                <a:spcPts val="0"/>
+              </a:spcAft>
+            </a:pPr>
+            <a:r>
+              <a:rPr lang="en-US" noProof="1"/>
+              <a:t xml:space="preserve">    return port.login(username, password);</a:t>
+            </a:r>
+          </a:p>
+          <a:p>
+            <a:pPr>
+              <a:lnSpc>
+                <a:spcPct val="100000"/>
+              </a:lnSpc>
+              <a:spcBef>
+                <a:spcPts val="0"/>
+              </a:spcBef>
+              <a:spcAft>
+                <a:spcPts val="0"/>
+              </a:spcAft>
+            </a:pPr>
+            <a:r>
+              <a:rPr lang="en-US" noProof="1"/>
+              <a:t xml:space="preserve">  }</a:t>
+            </a:r>
+          </a:p>
+          <a:p>
+            <a:pPr>
+              <a:lnSpc>
+                <a:spcPct val="100000"/>
+              </a:lnSpc>
+              <a:spcBef>
+                <a:spcPts val="0"/>
+              </a:spcBef>
+              <a:spcAft>
+                <a:spcPts val="0"/>
+              </a:spcAft>
+            </a:pPr>
+            <a:r>
+              <a:rPr lang="en-US" noProof="1"/>
+              <a:t xml:space="preserve">}</a:t>
+            </a:r>
+          </a:p>
+        </p:txBody>
+      </p:sp>
+      <p:sp>
+        <p:nvSpPr>
+          <p:cNvPr id="4" name="Text Placeholder 3">
+            <a:extLst>
+              <a:ext uri="{FF2B5EF4-FFF2-40B4-BE49-F238E27FC236}">
+                <a16:creationId xmlns:a16="http://schemas.microsoft.com/office/drawing/2014/main" id="{532B24EF-7A3C-74C9-6C54-DEF8F61E4574}"/>
+              </a:ext>
+            </a:extLst>
+          </p:cNvPr>
+          <p:cNvSpPr>
+            <a:spLocks noGrp="1"/>
+          </p:cNvSpPr>
+          <p:nvPr>
+            <p:ph type="body" sz="quarter" idx="12"/>
+          </p:nvPr>
+        </p:nvSpPr>
+        <p:spPr/>
+        <p:txBody>
+          <a:bodyPr/>
+          <a:lstStyle/>
+          <a:p>
+            <a:r>
               <a:rPr lang="es-MX"/>
-              <a:t> llama al servidor]</a:t>
-            </a:r>
-            <a:endParaRPr lang="es-EC"/>
-          </a:p>
-        </p:txBody>
-      </p:sp>
-      <p:sp>
-        <p:nvSpPr>
-          <p:cNvPr id="4" name="Text Placeholder 3">
-            <a:extLst>
-              <a:ext uri="{FF2B5EF4-FFF2-40B4-BE49-F238E27FC236}">
-                <a16:creationId xmlns:a16="http://schemas.microsoft.com/office/drawing/2014/main" id="{532B24EF-7A3C-74C9-6C54-DEF8F61E4574}"/>
-              </a:ext>
-            </a:extLst>
-          </p:cNvPr>
-          <p:cNvSpPr>
-            <a:spLocks noGrp="1"/>
-          </p:cNvSpPr>
-          <p:nvPr>
-            <p:ph type="body" sz="quarter" idx="12"/>
-          </p:nvPr>
-        </p:nvSpPr>
-        <p:spPr/>
-        <p:txBody>
-          <a:bodyPr/>
-          <a:lstStyle/>
+              <a:t>LoginWebService_Service y su puerto se generan desde el WSDL con Apache CXF (wsdl2java).</a:t>
+            </a:r>
+          </a:p>
           <a:p>
             <a:r>
               <a:rPr lang="es-MX"/>
-              <a:t>[Qué hace este fragmento.]</a:t>
-            </a:r>
-          </a:p>
-          <a:p>
-            <a:r>
-              <a:rPr lang="es-MX"/>
-              <a:t>[Cómo maneja errores o la sesión.]</a:t>
+              <a:t>El token devuelto se guarda en la sesión y se envía en las llamadas de catálogo y conversión.</a:t>
             </a:r>
             <a:endParaRPr lang="es-EC"/>
           </a:p>
@@ -11680,7 +12090,7 @@
           <a:p>
             <a:r>
               <a:rPr lang="es-MX"/>
-              <a:t>Conversión de Unidades [SOAP | RESTful] sin BDD en [JAVA | .NET]</a:t>
+              <a:t>Conversión de Unidades SOAP sin BDD en JAVA</a:t>
             </a:r>
             <a:endParaRPr lang="es-EC"/>
           </a:p>
@@ -11709,7 +12119,7 @@
           <a:p>
             <a:r>
               <a:rPr lang="pt-BR"/>
-              <a:t>[TI.1.X] · Arquitectura de Software</a:t>
+              <a:t>TI.1.1 · Arquitectura de Software</a:t>
             </a:r>
             <a:endParaRPr lang="es-EC"/>
           </a:p>
@@ -11751,7 +12161,7 @@
             </a:r>
             <a:r>
               <a:rPr lang="es-MX"/>
-              <a:t>  [Nombre Apellido] · [Nombre Apellido] · [Nombre Apellido]</a:t>
+              <a:t xml:space="preserve">  Diego Mateo Sosa Flores · Marcos David Escobar Vela · Carlos Isaac Ñato Caiza</a:t>
             </a:r>
           </a:p>
           <a:p>
@@ -11770,7 +12180,7 @@
             </a:r>
             <a:r>
               <a:rPr lang="es-MX"/>
-              <a:t>  [Ing. Nombre del tutor]</a:t>
+              <a:t xml:space="preserve">  Ing. Eduardo Mauricio Campaña Ortega</a:t>
             </a:r>
           </a:p>
           <a:p>
@@ -11781,7 +12191,7 @@
             </a:pPr>
             <a:r>
               <a:rPr lang="es-MX"/>
-              <a:t>NRC 36883 · Grupo 4 · [dd/mm/aaaa]</a:t>
+              <a:t>NRC 36883 · Grupo 4 · 29/10/2026</a:t>
             </a:r>
             <a:endParaRPr lang="es-EC"/>
           </a:p>
@@ -12152,7 +12562,7 @@
           <a:p>
             <a:r>
               <a:rPr lang="es-EC"/>
-              <a:t>[Tecnología] · patrón MVC</a:t>
+              <a:t>Java Swing + JAX-WS · patrón MVC</a:t>
             </a:r>
           </a:p>
         </p:txBody>
@@ -12239,7 +12649,7 @@
           <a:p>
             <a:r>
               <a:rPr lang="es-MX"/>
-              <a:t>Proyecto ESC_CON_UNI_[JAVA | DOTNET]_[SOAP | RESTful] creado en [IDE].</a:t>
+              <a:t>Proyecto ESC_CON_UNI_JAVA_SOAP creado en NetBeans 31.</a:t>
             </a:r>
           </a:p>
           <a:p>
@@ -12422,58 +12832,321 @@
           <a:p>
             <a:pPr>
               <a:lnSpc>
-                <a:spcPct val="110000"/>
+                <a:spcPct val="100000"/>
               </a:lnSpc>
+              <a:spcBef>
+                <a:spcPts val="0"/>
+              </a:spcBef>
+              <a:spcAft>
+                <a:spcPts val="0"/>
+              </a:spcAft>
             </a:pPr>
             <a:r>
-              <a:rPr lang="es-MX"/>
-              <a:t>[Pega aquí cómo el cliente</a:t>
+              <a:rPr lang="en-US" noProof="1"/>
+              <a:t xml:space="preserve">public static ConversorServicio crear(Sesion sesion) {</a:t>
             </a:r>
           </a:p>
           <a:p>
             <a:pPr>
               <a:lnSpc>
-                <a:spcPct val="110000"/>
+                <a:spcPct val="100000"/>
               </a:lnSpc>
+              <a:spcBef>
+                <a:spcPts val="0"/>
+              </a:spcBef>
+              <a:spcAft>
+                <a:spcPts val="0"/>
+              </a:spcAft>
             </a:pPr>
             <a:r>
+              <a:rPr lang="en-US" noProof="1"/>
+              <a:t xml:space="preserve">  return new ConversorServicio(</a:t>
+            </a:r>
+          </a:p>
+          <a:p>
+            <a:pPr>
+              <a:lnSpc>
+                <a:spcPct val="100000"/>
+              </a:lnSpc>
+              <a:spcBef>
+                <a:spcPts val="0"/>
+              </a:spcBef>
+              <a:spcAft>
+                <a:spcPts val="0"/>
+              </a:spcAft>
+            </a:pPr>
+            <a:r>
+              <a:rPr lang="en-US" noProof="1"/>
+              <a:t xml:space="preserve">      conTimeouts(new LoginWebService_Service()</a:t>
+            </a:r>
+          </a:p>
+          <a:p>
+            <a:pPr>
+              <a:lnSpc>
+                <a:spcPct val="100000"/>
+              </a:lnSpc>
+              <a:spcBef>
+                <a:spcPts val="0"/>
+              </a:spcBef>
+              <a:spcAft>
+                <a:spcPts val="0"/>
+              </a:spcAft>
+            </a:pPr>
+            <a:r>
+              <a:rPr lang="en-US" noProof="1"/>
+              <a:t xml:space="preserve">          .getLoginWebServicePort()),</a:t>
+            </a:r>
+          </a:p>
+          <a:p>
+            <a:pPr>
+              <a:lnSpc>
+                <a:spcPct val="100000"/>
+              </a:lnSpc>
+              <a:spcBef>
+                <a:spcPts val="0"/>
+              </a:spcBef>
+              <a:spcAft>
+                <a:spcPts val="0"/>
+              </a:spcAft>
+            </a:pPr>
+            <a:r>
+              <a:rPr lang="en-US" noProof="1"/>
+              <a:t xml:space="preserve">      conTimeouts(new ConversorWebService_Service()</a:t>
+            </a:r>
+          </a:p>
+          <a:p>
+            <a:pPr>
+              <a:lnSpc>
+                <a:spcPct val="100000"/>
+              </a:lnSpc>
+              <a:spcBef>
+                <a:spcPts val="0"/>
+              </a:spcBef>
+              <a:spcAft>
+                <a:spcPts val="0"/>
+              </a:spcAft>
+            </a:pPr>
+            <a:r>
+              <a:rPr lang="en-US" noProof="1"/>
+              <a:t xml:space="preserve">          .getConversorWebServicePort()),</a:t>
+            </a:r>
+          </a:p>
+          <a:p>
+            <a:pPr>
+              <a:lnSpc>
+                <a:spcPct val="100000"/>
+              </a:lnSpc>
+              <a:spcBef>
+                <a:spcPts val="0"/>
+              </a:spcBef>
+              <a:spcAft>
+                <a:spcPts val="0"/>
+              </a:spcAft>
+            </a:pPr>
+            <a:r>
+              <a:rPr lang="en-US" noProof="1"/>
+              <a:t xml:space="preserve">      sesion);</a:t>
+            </a:r>
+          </a:p>
+          <a:p>
+            <a:pPr>
+              <a:lnSpc>
+                <a:spcPct val="100000"/>
+              </a:lnSpc>
+              <a:spcBef>
+                <a:spcPts val="0"/>
+              </a:spcBef>
+              <a:spcAft>
+                <a:spcPts val="0"/>
+              </a:spcAft>
+            </a:pPr>
+            <a:r>
+              <a:rPr lang="en-US" noProof="1"/>
+              <a:t xml:space="preserve">}</a:t>
+            </a:r>
+          </a:p>
+          <a:p>
+            <a:pPr>
+              <a:lnSpc>
+                <a:spcPct val="100000"/>
+              </a:lnSpc>
+              <a:spcBef>
+                <a:spcPts val="0"/>
+              </a:spcBef>
+              <a:spcAft>
+                <a:spcPts val="0"/>
+              </a:spcAft>
+            </a:pPr>
+            <a:endParaRPr lang="en-US" noProof="1"/>
+          </a:p>
+          <a:p>
+            <a:pPr>
+              <a:lnSpc>
+                <a:spcPct val="100000"/>
+              </a:lnSpc>
+              <a:spcBef>
+                <a:spcPts val="0"/>
+              </a:spcBef>
+              <a:spcAft>
+                <a:spcPts val="0"/>
+              </a:spcAft>
+            </a:pPr>
+            <a:r>
+              <a:rPr lang="en-US" noProof="1"/>
+              <a:t xml:space="preserve">public void iniciarSesion(String usuario, String clave)</a:t>
+            </a:r>
+          </a:p>
+          <a:p>
+            <a:pPr>
+              <a:lnSpc>
+                <a:spcPct val="100000"/>
+              </a:lnSpc>
+              <a:spcBef>
+                <a:spcPts val="0"/>
+              </a:spcBef>
+              <a:spcAft>
+                <a:spcPts val="0"/>
+              </a:spcAft>
+            </a:pPr>
+            <a:r>
+              <a:rPr lang="en-US" noProof="1"/>
+              <a:t xml:space="preserve">    throws ServicioException {</a:t>
+            </a:r>
+          </a:p>
+          <a:p>
+            <a:pPr>
+              <a:lnSpc>
+                <a:spcPct val="100000"/>
+              </a:lnSpc>
+              <a:spcBef>
+                <a:spcPts val="0"/>
+              </a:spcBef>
+              <a:spcAft>
+                <a:spcPts val="0"/>
+              </a:spcAft>
+            </a:pPr>
+            <a:r>
+              <a:rPr lang="en-US" noProof="1"/>
+              <a:t xml:space="preserve">  sesion.cerrar();</a:t>
+            </a:r>
+          </a:p>
+          <a:p>
+            <a:pPr>
+              <a:lnSpc>
+                <a:spcPct val="100000"/>
+              </a:lnSpc>
+              <a:spcBef>
+                <a:spcPts val="0"/>
+              </a:spcBef>
+              <a:spcAft>
+                <a:spcPts val="0"/>
+              </a:spcAft>
+            </a:pPr>
+            <a:r>
+              <a:rPr lang="en-US" noProof="1"/>
+              <a:t xml:space="preserve">  LoginDTO respuesta = llamar(() -&gt; login.login(usuario, clave));</a:t>
+            </a:r>
+          </a:p>
+          <a:p>
+            <a:pPr>
+              <a:lnSpc>
+                <a:spcPct val="100000"/>
+              </a:lnSpc>
+              <a:spcBef>
+                <a:spcPts val="0"/>
+              </a:spcBef>
+              <a:spcAft>
+                <a:spcPts val="0"/>
+              </a:spcAft>
+            </a:pPr>
+            <a:r>
+              <a:rPr lang="en-US" noProof="1"/>
+              <a:t xml:space="preserve">  if (respuesta.getEstado() != EstadosEnum.OK)</a:t>
+            </a:r>
+          </a:p>
+          <a:p>
+            <a:pPr>
+              <a:lnSpc>
+                <a:spcPct val="100000"/>
+              </a:lnSpc>
+              <a:spcBef>
+                <a:spcPts val="0"/>
+              </a:spcBef>
+              <a:spcAft>
+                <a:spcPts val="0"/>
+              </a:spcAft>
+            </a:pPr>
+            <a:r>
+              <a:rPr lang="en-US" noProof="1"/>
+              <a:t xml:space="preserve">    throw new ServicioException(respuesta.getMensaje());</a:t>
+            </a:r>
+          </a:p>
+          <a:p>
+            <a:pPr>
+              <a:lnSpc>
+                <a:spcPct val="100000"/>
+              </a:lnSpc>
+              <a:spcBef>
+                <a:spcPts val="0"/>
+              </a:spcBef>
+              <a:spcAft>
+                <a:spcPts val="0"/>
+              </a:spcAft>
+            </a:pPr>
+            <a:r>
+              <a:rPr lang="en-US" noProof="1"/>
+              <a:t xml:space="preserve">  sesion.iniciar(usuario, respuesta.getToken());</a:t>
+            </a:r>
+          </a:p>
+          <a:p>
+            <a:pPr>
+              <a:lnSpc>
+                <a:spcPct val="100000"/>
+              </a:lnSpc>
+              <a:spcBef>
+                <a:spcPts val="0"/>
+              </a:spcBef>
+              <a:spcAft>
+                <a:spcPts val="0"/>
+              </a:spcAft>
+            </a:pPr>
+            <a:r>
+              <a:rPr lang="en-US" noProof="1"/>
+              <a:t xml:space="preserve">}</a:t>
+            </a:r>
+          </a:p>
+        </p:txBody>
+      </p:sp>
+      <p:sp>
+        <p:nvSpPr>
+          <p:cNvPr id="4" name="Text Placeholder 3">
+            <a:extLst>
+              <a:ext uri="{FF2B5EF4-FFF2-40B4-BE49-F238E27FC236}">
+                <a16:creationId xmlns:a16="http://schemas.microsoft.com/office/drawing/2014/main" id="{20A8AF34-9793-D88F-FF58-6E72CF9E4E62}"/>
+              </a:ext>
+            </a:extLst>
+          </p:cNvPr>
+          <p:cNvSpPr>
+            <a:spLocks noGrp="1"/>
+          </p:cNvSpPr>
+          <p:nvPr>
+            <p:ph type="body" sz="quarter" idx="12"/>
+          </p:nvPr>
+        </p:nvSpPr>
+        <p:spPr/>
+        <p:txBody>
+          <a:bodyPr/>
+          <a:lstStyle/>
+          <a:p>
+            <a:r>
               <a:rPr lang="es-MX"/>
-              <a:t> llama al servidor]</a:t>
-            </a:r>
-            <a:endParaRPr lang="es-EC"/>
-          </a:p>
-        </p:txBody>
-      </p:sp>
-      <p:sp>
-        <p:nvSpPr>
-          <p:cNvPr id="4" name="Text Placeholder 3">
-            <a:extLst>
-              <a:ext uri="{FF2B5EF4-FFF2-40B4-BE49-F238E27FC236}">
-                <a16:creationId xmlns:a16="http://schemas.microsoft.com/office/drawing/2014/main" id="{20A8AF34-9793-D88F-FF58-6E72CF9E4E62}"/>
-              </a:ext>
-            </a:extLst>
-          </p:cNvPr>
-          <p:cNvSpPr>
-            <a:spLocks noGrp="1"/>
-          </p:cNvSpPr>
-          <p:nvPr>
-            <p:ph type="body" sz="quarter" idx="12"/>
-          </p:nvPr>
-        </p:nvSpPr>
-        <p:spPr/>
-        <p:txBody>
-          <a:bodyPr/>
-          <a:lstStyle/>
+              <a:t>Crea los puertos SOAP generados con wsimport (JAX-WS) con tiempos de espera de 5 s y 15 s.</a:t>
+            </a:r>
+          </a:p>
           <a:p>
             <a:r>
               <a:rPr lang="es-MX"/>
-              <a:t>[Qué hace este fragmento.]</a:t>
-            </a:r>
-          </a:p>
-          <a:p>
-            <a:r>
-              <a:rPr lang="es-MX"/>
-              <a:t>[Cómo maneja errores o la sesión.]</a:t>
+              <a:t>Si el servidor responde con error o no hay conexión, lanza ServicioException y la ventana muestra el mensaje.</a:t>
             </a:r>
             <a:endParaRPr lang="es-EC"/>
           </a:p>
@@ -12904,7 +13577,7 @@
           <a:p>
             <a:r>
               <a:rPr lang="es-EC"/>
-              <a:t>[Tecnología] · patrón MVC</a:t>
+              <a:t>JSP / Servlets + JAX-WS · patrón MVC</a:t>
             </a:r>
           </a:p>
         </p:txBody>
@@ -12991,7 +13664,7 @@
           <a:p>
             <a:r>
               <a:rPr lang="es-MX"/>
-              <a:t>Proyecto WEB_CON_UNI_[JAVA | DOTNET]_[SOAP | RESTful] creado en [IDE].</a:t>
+              <a:t>Proyecto WEB_CON_UNI_JAVA_SOAP creado en NetBeans 31.</a:t>
             </a:r>
           </a:p>
           <a:p>
@@ -13174,58 +13847,324 @@
           <a:p>
             <a:pPr>
               <a:lnSpc>
-                <a:spcPct val="110000"/>
+                <a:spcPct val="100000"/>
               </a:lnSpc>
+              <a:spcBef>
+                <a:spcPts val="0"/>
+              </a:spcBef>
+              <a:spcAft>
+                <a:spcPts val="0"/>
+              </a:spcAft>
             </a:pPr>
             <a:r>
-              <a:rPr lang="es-MX"/>
-              <a:t>[Pega aquí cómo el cliente</a:t>
+              <a:rPr lang="en-US" noProof="1"/>
+              <a:t xml:space="preserve">@Override</a:t>
             </a:r>
           </a:p>
           <a:p>
             <a:pPr>
               <a:lnSpc>
-                <a:spcPct val="110000"/>
+                <a:spcPct val="100000"/>
               </a:lnSpc>
+              <a:spcBef>
+                <a:spcPts val="0"/>
+              </a:spcBef>
+              <a:spcAft>
+                <a:spcPts val="0"/>
+              </a:spcAft>
             </a:pPr>
             <a:r>
+              <a:rPr lang="en-US" noProof="1"/>
+              <a:t xml:space="preserve">protected void doPost(HttpServletRequest request,</a:t>
+            </a:r>
+          </a:p>
+          <a:p>
+            <a:pPr>
+              <a:lnSpc>
+                <a:spcPct val="100000"/>
+              </a:lnSpc>
+              <a:spcBef>
+                <a:spcPts val="0"/>
+              </a:spcBef>
+              <a:spcAft>
+                <a:spcPts val="0"/>
+              </a:spcAft>
+            </a:pPr>
+            <a:r>
+              <a:rPr lang="en-US" noProof="1"/>
+              <a:t xml:space="preserve">    HttpServletResponse response)</a:t>
+            </a:r>
+          </a:p>
+          <a:p>
+            <a:pPr>
+              <a:lnSpc>
+                <a:spcPct val="100000"/>
+              </a:lnSpc>
+              <a:spcBef>
+                <a:spcPts val="0"/>
+              </a:spcBef>
+              <a:spcAft>
+                <a:spcPts val="0"/>
+              </a:spcAft>
+            </a:pPr>
+            <a:r>
+              <a:rPr lang="en-US" noProof="1"/>
+              <a:t xml:space="preserve">    throws ServletException, IOException {</a:t>
+            </a:r>
+          </a:p>
+          <a:p>
+            <a:pPr>
+              <a:lnSpc>
+                <a:spcPct val="100000"/>
+              </a:lnSpc>
+              <a:spcBef>
+                <a:spcPts val="0"/>
+              </a:spcBef>
+              <a:spcAft>
+                <a:spcPts val="0"/>
+              </a:spcAft>
+            </a:pPr>
+            <a:r>
+              <a:rPr lang="en-US" noProof="1"/>
+              <a:t xml:space="preserve">  String usuario = request.getParameter("usuario");</a:t>
+            </a:r>
+          </a:p>
+          <a:p>
+            <a:pPr>
+              <a:lnSpc>
+                <a:spcPct val="100000"/>
+              </a:lnSpc>
+              <a:spcBef>
+                <a:spcPts val="0"/>
+              </a:spcBef>
+              <a:spcAft>
+                <a:spcPts val="0"/>
+              </a:spcAft>
+            </a:pPr>
+            <a:r>
+              <a:rPr lang="en-US" noProof="1"/>
+              <a:t xml:space="preserve">  String clave = request.getParameter("clave");</a:t>
+            </a:r>
+          </a:p>
+          <a:p>
+            <a:pPr>
+              <a:lnSpc>
+                <a:spcPct val="100000"/>
+              </a:lnSpc>
+              <a:spcBef>
+                <a:spcPts val="0"/>
+              </a:spcBef>
+              <a:spcAft>
+                <a:spcPts val="0"/>
+              </a:spcAft>
+            </a:pPr>
+            <a:r>
+              <a:rPr lang="en-US" noProof="1"/>
+              <a:t xml:space="preserve">  Sesion sesion = new Sesion();</a:t>
+            </a:r>
+          </a:p>
+          <a:p>
+            <a:pPr>
+              <a:lnSpc>
+                <a:spcPct val="100000"/>
+              </a:lnSpc>
+              <a:spcBef>
+                <a:spcPts val="0"/>
+              </a:spcBef>
+              <a:spcAft>
+                <a:spcPts val="0"/>
+              </a:spcAft>
+            </a:pPr>
+            <a:r>
+              <a:rPr lang="en-US" noProof="1"/>
+              <a:t xml:space="preserve">  try {</a:t>
+            </a:r>
+          </a:p>
+          <a:p>
+            <a:pPr>
+              <a:lnSpc>
+                <a:spcPct val="100000"/>
+              </a:lnSpc>
+              <a:spcBef>
+                <a:spcPts val="0"/>
+              </a:spcBef>
+              <a:spcAft>
+                <a:spcPts val="0"/>
+              </a:spcAft>
+            </a:pPr>
+            <a:r>
+              <a:rPr lang="en-US" noProof="1"/>
+              <a:t xml:space="preserve">    ConversorServicio servicio = FabricaServicios</a:t>
+            </a:r>
+          </a:p>
+          <a:p>
+            <a:pPr>
+              <a:lnSpc>
+                <a:spcPct val="100000"/>
+              </a:lnSpc>
+              <a:spcBef>
+                <a:spcPts val="0"/>
+              </a:spcBef>
+              <a:spcAft>
+                <a:spcPts val="0"/>
+              </a:spcAft>
+            </a:pPr>
+            <a:r>
+              <a:rPr lang="en-US" noProof="1"/>
+              <a:t xml:space="preserve">        .de(getServletContext()).crearServicio(sesion);</a:t>
+            </a:r>
+          </a:p>
+          <a:p>
+            <a:pPr>
+              <a:lnSpc>
+                <a:spcPct val="100000"/>
+              </a:lnSpc>
+              <a:spcBef>
+                <a:spcPts val="0"/>
+              </a:spcBef>
+              <a:spcAft>
+                <a:spcPts val="0"/>
+              </a:spcAft>
+            </a:pPr>
+            <a:r>
+              <a:rPr lang="en-US" noProof="1"/>
+              <a:t xml:space="preserve">    servicio.iniciarSesion(usuario.trim(), clave);</a:t>
+            </a:r>
+          </a:p>
+          <a:p>
+            <a:pPr>
+              <a:lnSpc>
+                <a:spcPct val="100000"/>
+              </a:lnSpc>
+              <a:spcBef>
+                <a:spcPts val="0"/>
+              </a:spcBef>
+              <a:spcAft>
+                <a:spcPts val="0"/>
+              </a:spcAft>
+            </a:pPr>
+            <a:r>
+              <a:rPr lang="en-US" noProof="1"/>
+              <a:t xml:space="preserve">    SesionUsuario.guardar(nuevaSesion(request), sesion, servicio);</a:t>
+            </a:r>
+          </a:p>
+          <a:p>
+            <a:pPr>
+              <a:lnSpc>
+                <a:spcPct val="100000"/>
+              </a:lnSpc>
+              <a:spcBef>
+                <a:spcPts val="0"/>
+              </a:spcBef>
+              <a:spcAft>
+                <a:spcPts val="0"/>
+              </a:spcAft>
+            </a:pPr>
+            <a:r>
+              <a:rPr lang="en-US" noProof="1"/>
+              <a:t xml:space="preserve">    response.sendRedirect(request.getContextPath() + "/menu");</a:t>
+            </a:r>
+          </a:p>
+          <a:p>
+            <a:pPr>
+              <a:lnSpc>
+                <a:spcPct val="100000"/>
+              </a:lnSpc>
+              <a:spcBef>
+                <a:spcPts val="0"/>
+              </a:spcBef>
+              <a:spcAft>
+                <a:spcPts val="0"/>
+              </a:spcAft>
+            </a:pPr>
+            <a:r>
+              <a:rPr lang="en-US" noProof="1"/>
+              <a:t xml:space="preserve">  } catch (ServicioException e) {</a:t>
+            </a:r>
+          </a:p>
+          <a:p>
+            <a:pPr>
+              <a:lnSpc>
+                <a:spcPct val="100000"/>
+              </a:lnSpc>
+              <a:spcBef>
+                <a:spcPts val="0"/>
+              </a:spcBef>
+              <a:spcAft>
+                <a:spcPts val="0"/>
+              </a:spcAft>
+            </a:pPr>
+            <a:r>
+              <a:rPr lang="en-US" noProof="1"/>
+              <a:t xml:space="preserve">    mostrar(request, response, usuario, e.getMessage());</a:t>
+            </a:r>
+          </a:p>
+          <a:p>
+            <a:pPr>
+              <a:lnSpc>
+                <a:spcPct val="100000"/>
+              </a:lnSpc>
+              <a:spcBef>
+                <a:spcPts val="0"/>
+              </a:spcBef>
+              <a:spcAft>
+                <a:spcPts val="0"/>
+              </a:spcAft>
+            </a:pPr>
+            <a:r>
+              <a:rPr lang="en-US" noProof="1"/>
+              <a:t xml:space="preserve">  }</a:t>
+            </a:r>
+          </a:p>
+          <a:p>
+            <a:pPr>
+              <a:lnSpc>
+                <a:spcPct val="100000"/>
+              </a:lnSpc>
+              <a:spcBef>
+                <a:spcPts val="0"/>
+              </a:spcBef>
+              <a:spcAft>
+                <a:spcPts val="0"/>
+              </a:spcAft>
+            </a:pPr>
+            <a:r>
+              <a:rPr lang="en-US" noProof="1"/>
+              <a:t xml:space="preserve">}</a:t>
+            </a:r>
+          </a:p>
+        </p:txBody>
+      </p:sp>
+      <p:sp>
+        <p:nvSpPr>
+          <p:cNvPr id="4" name="Text Placeholder 3">
+            <a:extLst>
+              <a:ext uri="{FF2B5EF4-FFF2-40B4-BE49-F238E27FC236}">
+                <a16:creationId xmlns:a16="http://schemas.microsoft.com/office/drawing/2014/main" id="{083ED04C-DD32-D005-5F14-AF65141A1F3E}"/>
+              </a:ext>
+            </a:extLst>
+          </p:cNvPr>
+          <p:cNvSpPr>
+            <a:spLocks noGrp="1"/>
+          </p:cNvSpPr>
+          <p:nvPr>
+            <p:ph type="body" sz="quarter" idx="12"/>
+          </p:nvPr>
+        </p:nvSpPr>
+        <p:spPr/>
+        <p:txBody>
+          <a:bodyPr/>
+          <a:lstStyle/>
+          <a:p>
+            <a:r>
               <a:rPr lang="es-MX"/>
-              <a:t> llama al servidor]</a:t>
-            </a:r>
-            <a:endParaRPr lang="es-EC"/>
-          </a:p>
-        </p:txBody>
-      </p:sp>
-      <p:sp>
-        <p:nvSpPr>
-          <p:cNvPr id="4" name="Text Placeholder 3">
-            <a:extLst>
-              <a:ext uri="{FF2B5EF4-FFF2-40B4-BE49-F238E27FC236}">
-                <a16:creationId xmlns:a16="http://schemas.microsoft.com/office/drawing/2014/main" id="{083ED04C-DD32-D005-5F14-AF65141A1F3E}"/>
-              </a:ext>
-            </a:extLst>
-          </p:cNvPr>
-          <p:cNvSpPr>
-            <a:spLocks noGrp="1"/>
-          </p:cNvSpPr>
-          <p:nvPr>
-            <p:ph type="body" sz="quarter" idx="12"/>
-          </p:nvPr>
-        </p:nvSpPr>
-        <p:spPr/>
-        <p:txBody>
-          <a:bodyPr/>
-          <a:lstStyle/>
+              <a:t>El servlet recibe el formulario de login y llama al servidor SOAP mediante ConversorServicio (JAX-WS).</a:t>
+            </a:r>
+          </a:p>
           <a:p>
             <a:r>
               <a:rPr lang="es-MX"/>
-              <a:t>[Qué hace este fragmento.]</a:t>
-            </a:r>
-          </a:p>
-          <a:p>
-            <a:r>
-              <a:rPr lang="es-MX"/>
-              <a:t>[Cómo maneja errores o la sesión.]</a:t>
+              <a:t>Guarda la sesión en una HttpSession nueva; si falla, vuelve a mostrar el login con el mensaje de error.</a:t>
             </a:r>
             <a:endParaRPr lang="es-EC"/>
           </a:p>
@@ -13656,7 +14595,7 @@
           <a:p>
             <a:r>
               <a:rPr lang="es-EC"/>
-              <a:t>[Tecnología] · patrón MVC</a:t>
+              <a:t>Android (Java) · patrón MVC</a:t>
             </a:r>
           </a:p>
         </p:txBody>
@@ -13778,7 +14717,7 @@
             </a:r>
             <a:r>
               <a:rPr lang="es-EC" sz="2200"/>
-              <a:t>   Servidor [SOAP | RESTful]</a:t>
+              <a:t xml:space="preserve">   Servidor SOAP</a:t>
             </a:r>
           </a:p>
           <a:p>
@@ -14068,7 +15007,7 @@
           <a:p>
             <a:r>
               <a:rPr lang="es-MX"/>
-              <a:t>Proyecto MOV_CON_UNI_[JAVA | DOTNET]_[SOAP | RESTful] creado en [IDE].</a:t>
+              <a:t>Proyecto MOV_CON_UNI_JAVA_SOAP creado en NetBeans 31 (Java with Gradle).</a:t>
             </a:r>
           </a:p>
           <a:p>
@@ -14251,58 +15190,341 @@
           <a:p>
             <a:pPr>
               <a:lnSpc>
-                <a:spcPct val="110000"/>
+                <a:spcPct val="100000"/>
               </a:lnSpc>
+              <a:spcBef>
+                <a:spcPts val="0"/>
+              </a:spcBef>
+              <a:spcAft>
+                <a:spcPts val="0"/>
+              </a:spcAft>
             </a:pPr>
             <a:r>
-              <a:rPr lang="es-MX"/>
-              <a:t>[Pega aquí cómo el cliente</a:t>
+              <a:rPr lang="en-US" noProof="1"/>
+              <a:t xml:space="preserve">public String enviar(String url, String sobre) throws IOException {</a:t>
             </a:r>
           </a:p>
           <a:p>
             <a:pPr>
               <a:lnSpc>
-                <a:spcPct val="110000"/>
+                <a:spcPct val="100000"/>
               </a:lnSpc>
+              <a:spcBef>
+                <a:spcPts val="0"/>
+              </a:spcBef>
+              <a:spcAft>
+                <a:spcPts val="0"/>
+              </a:spcAft>
             </a:pPr>
             <a:r>
+              <a:rPr lang="en-US" noProof="1"/>
+              <a:t xml:space="preserve">  HttpURLConnection conexion =</a:t>
+            </a:r>
+          </a:p>
+          <a:p>
+            <a:pPr>
+              <a:lnSpc>
+                <a:spcPct val="100000"/>
+              </a:lnSpc>
+              <a:spcBef>
+                <a:spcPts val="0"/>
+              </a:spcBef>
+              <a:spcAft>
+                <a:spcPts val="0"/>
+              </a:spcAft>
+            </a:pPr>
+            <a:r>
+              <a:rPr lang="en-US" noProof="1"/>
+              <a:t xml:space="preserve">      (HttpURLConnection) new URL(url).openConnection();</a:t>
+            </a:r>
+          </a:p>
+          <a:p>
+            <a:pPr>
+              <a:lnSpc>
+                <a:spcPct val="100000"/>
+              </a:lnSpc>
+              <a:spcBef>
+                <a:spcPts val="0"/>
+              </a:spcBef>
+              <a:spcAft>
+                <a:spcPts val="0"/>
+              </a:spcAft>
+            </a:pPr>
+            <a:r>
+              <a:rPr lang="en-US" noProof="1"/>
+              <a:t xml:space="preserve">  conexion.setRequestMethod("POST");</a:t>
+            </a:r>
+          </a:p>
+          <a:p>
+            <a:pPr>
+              <a:lnSpc>
+                <a:spcPct val="100000"/>
+              </a:lnSpc>
+              <a:spcBef>
+                <a:spcPts val="0"/>
+              </a:spcBef>
+              <a:spcAft>
+                <a:spcPts val="0"/>
+              </a:spcAft>
+            </a:pPr>
+            <a:r>
+              <a:rPr lang="en-US" noProof="1"/>
+              <a:t xml:space="preserve">  conexion.setConnectTimeout(tiempoEsperaMs);</a:t>
+            </a:r>
+          </a:p>
+          <a:p>
+            <a:pPr>
+              <a:lnSpc>
+                <a:spcPct val="100000"/>
+              </a:lnSpc>
+              <a:spcBef>
+                <a:spcPts val="0"/>
+              </a:spcBef>
+              <a:spcAft>
+                <a:spcPts val="0"/>
+              </a:spcAft>
+            </a:pPr>
+            <a:r>
+              <a:rPr lang="en-US" noProof="1"/>
+              <a:t xml:space="preserve">  conexion.setReadTimeout(tiempoEsperaMs);</a:t>
+            </a:r>
+          </a:p>
+          <a:p>
+            <a:pPr>
+              <a:lnSpc>
+                <a:spcPct val="100000"/>
+              </a:lnSpc>
+              <a:spcBef>
+                <a:spcPts val="0"/>
+              </a:spcBef>
+              <a:spcAft>
+                <a:spcPts val="0"/>
+              </a:spcAft>
+            </a:pPr>
+            <a:r>
+              <a:rPr lang="en-US" noProof="1"/>
+              <a:t xml:space="preserve">  conexion.setDoOutput(true);</a:t>
+            </a:r>
+          </a:p>
+          <a:p>
+            <a:pPr>
+              <a:lnSpc>
+                <a:spcPct val="100000"/>
+              </a:lnSpc>
+              <a:spcBef>
+                <a:spcPts val="0"/>
+              </a:spcBef>
+              <a:spcAft>
+                <a:spcPts val="0"/>
+              </a:spcAft>
+            </a:pPr>
+            <a:r>
+              <a:rPr lang="en-US" noProof="1"/>
+              <a:t xml:space="preserve">  conexion.setRequestProperty("Content-Type",</a:t>
+            </a:r>
+          </a:p>
+          <a:p>
+            <a:pPr>
+              <a:lnSpc>
+                <a:spcPct val="100000"/>
+              </a:lnSpc>
+              <a:spcBef>
+                <a:spcPts val="0"/>
+              </a:spcBef>
+              <a:spcAft>
+                <a:spcPts val="0"/>
+              </a:spcAft>
+            </a:pPr>
+            <a:r>
+              <a:rPr lang="en-US" noProof="1"/>
+              <a:t xml:space="preserve">      "text/xml; charset=utf-8");</a:t>
+            </a:r>
+          </a:p>
+          <a:p>
+            <a:pPr>
+              <a:lnSpc>
+                <a:spcPct val="100000"/>
+              </a:lnSpc>
+              <a:spcBef>
+                <a:spcPts val="0"/>
+              </a:spcBef>
+              <a:spcAft>
+                <a:spcPts val="0"/>
+              </a:spcAft>
+            </a:pPr>
+            <a:r>
+              <a:rPr lang="en-US" noProof="1"/>
+              <a:t xml:space="preserve">  conexion.setRequestProperty("SOAPAction", "\"\"");</a:t>
+            </a:r>
+          </a:p>
+          <a:p>
+            <a:pPr>
+              <a:lnSpc>
+                <a:spcPct val="100000"/>
+              </a:lnSpc>
+              <a:spcBef>
+                <a:spcPts val="0"/>
+              </a:spcBef>
+              <a:spcAft>
+                <a:spcPts val="0"/>
+              </a:spcAft>
+            </a:pPr>
+            <a:r>
+              <a:rPr lang="en-US" noProof="1"/>
+              <a:t xml:space="preserve">  try (OutputStream salida = conexion.getOutputStream()) {</a:t>
+            </a:r>
+          </a:p>
+          <a:p>
+            <a:pPr>
+              <a:lnSpc>
+                <a:spcPct val="100000"/>
+              </a:lnSpc>
+              <a:spcBef>
+                <a:spcPts val="0"/>
+              </a:spcBef>
+              <a:spcAft>
+                <a:spcPts val="0"/>
+              </a:spcAft>
+            </a:pPr>
+            <a:r>
+              <a:rPr lang="en-US" noProof="1"/>
+              <a:t xml:space="preserve">    salida.write(sobre.getBytes(StandardCharsets.UTF_8));</a:t>
+            </a:r>
+          </a:p>
+          <a:p>
+            <a:pPr>
+              <a:lnSpc>
+                <a:spcPct val="100000"/>
+              </a:lnSpc>
+              <a:spcBef>
+                <a:spcPts val="0"/>
+              </a:spcBef>
+              <a:spcAft>
+                <a:spcPts val="0"/>
+              </a:spcAft>
+            </a:pPr>
+            <a:r>
+              <a:rPr lang="en-US" noProof="1"/>
+              <a:t xml:space="preserve">  }</a:t>
+            </a:r>
+          </a:p>
+          <a:p>
+            <a:pPr>
+              <a:lnSpc>
+                <a:spcPct val="100000"/>
+              </a:lnSpc>
+              <a:spcBef>
+                <a:spcPts val="0"/>
+              </a:spcBef>
+              <a:spcAft>
+                <a:spcPts val="0"/>
+              </a:spcAft>
+            </a:pPr>
+            <a:r>
+              <a:rPr lang="en-US" noProof="1"/>
+              <a:t xml:space="preserve">  int codigo = conexion.getResponseCode();</a:t>
+            </a:r>
+          </a:p>
+          <a:p>
+            <a:pPr>
+              <a:lnSpc>
+                <a:spcPct val="100000"/>
+              </a:lnSpc>
+              <a:spcBef>
+                <a:spcPts val="0"/>
+              </a:spcBef>
+              <a:spcAft>
+                <a:spcPts val="0"/>
+              </a:spcAft>
+            </a:pPr>
+            <a:r>
+              <a:rPr lang="en-US" noProof="1"/>
+              <a:t xml:space="preserve">  if (codigo == HttpURLConnection.HTTP_OK)</a:t>
+            </a:r>
+          </a:p>
+          <a:p>
+            <a:pPr>
+              <a:lnSpc>
+                <a:spcPct val="100000"/>
+              </a:lnSpc>
+              <a:spcBef>
+                <a:spcPts val="0"/>
+              </a:spcBef>
+              <a:spcAft>
+                <a:spcPts val="0"/>
+              </a:spcAft>
+            </a:pPr>
+            <a:r>
+              <a:rPr lang="en-US" noProof="1"/>
+              <a:t xml:space="preserve">    return leer(conexion.getInputStream());</a:t>
+            </a:r>
+          </a:p>
+          <a:p>
+            <a:pPr>
+              <a:lnSpc>
+                <a:spcPct val="100000"/>
+              </a:lnSpc>
+              <a:spcBef>
+                <a:spcPts val="0"/>
+              </a:spcBef>
+              <a:spcAft>
+                <a:spcPts val="0"/>
+              </a:spcAft>
+            </a:pPr>
+            <a:r>
+              <a:rPr lang="en-US" noProof="1"/>
+              <a:t xml:space="preserve">  throw new HttpEstadoException(codigo, url);</a:t>
+            </a:r>
+          </a:p>
+          <a:p>
+            <a:pPr>
+              <a:lnSpc>
+                <a:spcPct val="100000"/>
+              </a:lnSpc>
+              <a:spcBef>
+                <a:spcPts val="0"/>
+              </a:spcBef>
+              <a:spcAft>
+                <a:spcPts val="0"/>
+              </a:spcAft>
+            </a:pPr>
+            <a:r>
+              <a:rPr lang="en-US" noProof="1"/>
+              <a:t xml:space="preserve">}</a:t>
+            </a:r>
+          </a:p>
+        </p:txBody>
+      </p:sp>
+      <p:sp>
+        <p:nvSpPr>
+          <p:cNvPr id="4" name="Text Placeholder 3">
+            <a:extLst>
+              <a:ext uri="{FF2B5EF4-FFF2-40B4-BE49-F238E27FC236}">
+                <a16:creationId xmlns:a16="http://schemas.microsoft.com/office/drawing/2014/main" id="{8FA2B0E7-A824-A64D-CD4D-F66FF99B63E7}"/>
+              </a:ext>
+            </a:extLst>
+          </p:cNvPr>
+          <p:cNvSpPr>
+            <a:spLocks noGrp="1"/>
+          </p:cNvSpPr>
+          <p:nvPr>
+            <p:ph type="body" sz="quarter" idx="12"/>
+          </p:nvPr>
+        </p:nvSpPr>
+        <p:spPr/>
+        <p:txBody>
+          <a:bodyPr/>
+          <a:lstStyle/>
+          <a:p>
+            <a:r>
               <a:rPr lang="es-MX"/>
-              <a:t> llama al servidor]</a:t>
-            </a:r>
-            <a:endParaRPr lang="es-EC"/>
-          </a:p>
-        </p:txBody>
-      </p:sp>
-      <p:sp>
-        <p:nvSpPr>
-          <p:cNvPr id="4" name="Text Placeholder 3">
-            <a:extLst>
-              <a:ext uri="{FF2B5EF4-FFF2-40B4-BE49-F238E27FC236}">
-                <a16:creationId xmlns:a16="http://schemas.microsoft.com/office/drawing/2014/main" id="{8FA2B0E7-A824-A64D-CD4D-F66FF99B63E7}"/>
-              </a:ext>
-            </a:extLst>
-          </p:cNvPr>
-          <p:cNvSpPr>
-            <a:spLocks noGrp="1"/>
-          </p:cNvSpPr>
-          <p:nvPr>
-            <p:ph type="body" sz="quarter" idx="12"/>
-          </p:nvPr>
-        </p:nvSpPr>
-        <p:spPr/>
-        <p:txBody>
-          <a:bodyPr/>
-          <a:lstStyle/>
+              <a:t>Android no incluye JAX-WS: la app arma el sobre SOAP en XML y lo envía por HTTP POST.</a:t>
+            </a:r>
+          </a:p>
           <a:p>
             <a:r>
               <a:rPr lang="es-MX"/>
-              <a:t>[Qué hace este fragmento.]</a:t>
-            </a:r>
-          </a:p>
-          <a:p>
-            <a:r>
-              <a:rPr lang="es-MX"/>
-              <a:t>[Cómo maneja errores o la sesión.]</a:t>
+              <a:t>Usa tiempos de espera de 15 s (SoapConfig) y lanza HttpEstadoException si el servidor responde con error.</a:t>
             </a:r>
             <a:endParaRPr lang="es-EC"/>
           </a:p>
@@ -16492,19 +17714,19 @@
           <a:p>
             <a:r>
               <a:rPr lang="es-MX"/>
-              <a:t>[Pruebas automáticas: N pruebas, todas correctas.]</a:t>
+              <a:t>216 pruebas automáticas: escritorio (65), web (73) y móvil (78).</a:t>
             </a:r>
           </a:p>
           <a:p>
             <a:r>
               <a:rPr lang="es-MX"/>
-              <a:t>[Herramienta usada: JUnit | xUnit].</a:t>
+              <a:t>Herramienta usada: JUnit 5 (y Mockito en el cliente web).</a:t>
             </a:r>
           </a:p>
           <a:p>
             <a:r>
               <a:rPr lang="es-MX"/>
-              <a:t>[Observaciones encontradas durante las pruebas.]</a:t>
+              <a:t>El servidor se probó además con SoapUI (Conversor-soapui-project.xml).</a:t>
             </a:r>
             <a:endParaRPr lang="es-EC"/>
           </a:p>
@@ -16669,7 +17891,7 @@
           <a:p>
             <a:r>
               <a:rPr lang="es-MX"/>
-              <a:t>El servidor [SOAP | RESTful] fue consumido por cuatro clientes distintos sin cambiar su lógica, lo que muestra la interoperabilidad de una arquitectura orientada a servicios.</a:t>
+              <a:t>El servidor SOAP fue consumido por cuatro clientes distintos sin cambiar su lógica, lo que muestra la interoperabilidad de una arquitectura orientada a servicios.</a:t>
             </a:r>
           </a:p>
           <a:p>
@@ -16687,7 +17909,7 @@
           <a:p>
             <a:r>
               <a:rPr lang="es-MX"/>
-              <a:t>[Conclusión propia del proyecto.]</a:t>
+              <a:t>Payara Server con JAX-WS generó automáticamente el contrato WSDL y procesó los mensajes XML según Jakarta EE.</a:t>
             </a:r>
             <a:endParaRPr lang="es-EC"/>
           </a:p>
@@ -16840,7 +18062,7 @@
           <a:p>
             <a:r>
               <a:rPr lang="es-MX"/>
-              <a:t>Usar HTTPS [y WS-Security] para proteger el token en la red.</a:t>
+              <a:t>Usar HTTPS y WS-Security para proteger el token en la red.</a:t>
             </a:r>
           </a:p>
           <a:p>
@@ -16852,7 +18074,7 @@
           <a:p>
             <a:r>
               <a:rPr lang="es-MX"/>
-              <a:t>[Recomendación propia del proyecto.]</a:t>
+              <a:t>Incorporar análisis estático de código para asegurar que los cambios no rompan el contrato WSDL expuesto.</a:t>
             </a:r>
             <a:endParaRPr lang="es-EC"/>
           </a:p>
@@ -17039,7 +18261,7 @@
             </a:pPr>
             <a:r>
               <a:rPr lang="es-EC" sz="1500"/>
-              <a:t>[Autor. (Año). Título. Editorial o URL.]</a:t>
+              <a:t>Payara Services. (2026). Platform engineering for enterprise Java. https://payara.fish/</a:t>
             </a:r>
           </a:p>
         </p:txBody>
@@ -17288,7 +18510,7 @@
             </a:pPr>
             <a:r>
               <a:rPr lang="es-MX"/>
-              <a:t>Desarrollar un sistema de conversión de unidades basado en un servicio web [SOAP | RESTful] en [JAVA | .NET], sin base de datos, consumido por clientes de consola, escritorio, web y móvil.</a:t>
+              <a:t>Desarrollar un sistema de conversión de unidades basado en un servicio web SOAP en JAVA, sin base de datos, consumido por clientes de consola, escritorio, web y móvil.</a:t>
             </a:r>
             <a:endParaRPr lang="es-EC"/>
           </a:p>
@@ -17331,7 +18553,7 @@
           <a:p>
             <a:r>
               <a:rPr lang="es-MX"/>
-              <a:t>Implementar el servidor [SOAP | RESTful] con autenticación por token y conversión de seis magnitudes.</a:t>
+              <a:t>Implementar el servidor SOAP con autenticación por token y conversión de seis magnitudes.</a:t>
             </a:r>
           </a:p>
           <a:p>
@@ -17577,7 +18799,7 @@
           <a:p>
             <a:r>
               <a:rPr lang="es-MX"/>
-              <a:t>[SOAP y WSDL | REST y JSON]</a:t>
+              <a:t>SOAP y WSDL</a:t>
             </a:r>
             <a:endParaRPr lang="es-EC"/>
           </a:p>
@@ -17606,19 +18828,13 @@
           <a:p>
             <a:r>
               <a:rPr lang="es-MX"/>
-              <a:t>[SOAP] Intercambia mensajes XML dentro de un sobre (Envelope). Un contrato WSDL describe las operaciones del servicio.</a:t>
+              <a:t>Intercambia mensajes XML dentro de un sobre (Envelope). Un contrato WSDL describe las operaciones del servicio.</a:t>
             </a:r>
           </a:p>
           <a:p>
             <a:r>
               <a:rPr lang="es-MX"/>
-              <a:t>[RESTful] Expone recursos por URL que se usan con verbos HTTP (GET, POST) e intercambian datos en JSON.</a:t>
-            </a:r>
-          </a:p>
-          <a:p>
-            <a:r>
-              <a:rPr lang="es-MX"/>
-              <a:t>[Borra la opción que no corresponde y agrega una ventaja del protocolo.]</a:t>
+              <a:t>Ventaja: los clientes se generan automáticamente desde el WSDL (wsimport y Apache CXF).</a:t>
             </a:r>
             <a:endParaRPr lang="es-EC"/>
           </a:p>
@@ -18234,7 +19450,7 @@
                           </a:solidFill>
                           <a:latin typeface="Segoe UI" panose="020B0502040204020203" pitchFamily="34" charset="0"/>
                         </a:rPr>
-                        <a:t>[Ej.: ASP.NET Core + SoapCore | Jakarta EE en Payara]</a:t>
+                        <a:t>Jakarta EE en Payara (JAX-WS)</a:t>
                       </a:r>
                       <a:endParaRPr lang="es-EC" sz="1400">
                         <a:solidFill>
@@ -18272,7 +19488,7 @@
                           </a:solidFill>
                           <a:latin typeface="Segoe UI" panose="020B0502040204020203" pitchFamily="34" charset="0"/>
                         </a:rPr>
-                        <a:t>[x.y]</a:t>
+                        <a:t>Jakarta EE 11</a:t>
                       </a:r>
                     </a:p>
                   </a:txBody>
@@ -18343,7 +19559,7 @@
                           </a:solidFill>
                           <a:latin typeface="Segoe UI" panose="020B0502040204020203" pitchFamily="34" charset="0"/>
                         </a:rPr>
-                        <a:t>[Tecnología]</a:t>
+                        <a:t>Java + Apache CXF (wsdl2java)</a:t>
                       </a:r>
                     </a:p>
                   </a:txBody>
@@ -18375,7 +19591,7 @@
                           </a:solidFill>
                           <a:latin typeface="Segoe UI" panose="020B0502040204020203" pitchFamily="34" charset="0"/>
                         </a:rPr>
-                        <a:t>[x.y]</a:t>
+                        <a:t>Java 21 · CXF 4.1</a:t>
                       </a:r>
                     </a:p>
                   </a:txBody>
@@ -18446,7 +19662,7 @@
                           </a:solidFill>
                           <a:latin typeface="Segoe UI" panose="020B0502040204020203" pitchFamily="34" charset="0"/>
                         </a:rPr>
-                        <a:t>[Tecnología]</a:t>
+                        <a:t>Java Swing + JAX-WS (wsimport)</a:t>
                       </a:r>
                     </a:p>
                   </a:txBody>
@@ -18478,7 +19694,7 @@
                           </a:solidFill>
                           <a:latin typeface="Segoe UI" panose="020B0502040204020203" pitchFamily="34" charset="0"/>
                         </a:rPr>
-                        <a:t>[x.y]</a:t>
+                        <a:t>Java 25 · JAX-WS 4.0</a:t>
                       </a:r>
                     </a:p>
                   </a:txBody>
@@ -18549,7 +19765,7 @@
                           </a:solidFill>
                           <a:latin typeface="Segoe UI" panose="020B0502040204020203" pitchFamily="34" charset="0"/>
                         </a:rPr>
-                        <a:t>[Tecnología]</a:t>
+                        <a:t>JSP / Servlets + JAX-WS</a:t>
                       </a:r>
                     </a:p>
                   </a:txBody>
@@ -18581,7 +19797,7 @@
                           </a:solidFill>
                           <a:latin typeface="Segoe UI" panose="020B0502040204020203" pitchFamily="34" charset="0"/>
                         </a:rPr>
-                        <a:t>[x.y]</a:t>
+                        <a:t>Jakarta EE 11</a:t>
                       </a:r>
                     </a:p>
                   </a:txBody>
@@ -18652,7 +19868,7 @@
                           </a:solidFill>
                           <a:latin typeface="Segoe UI" panose="020B0502040204020203" pitchFamily="34" charset="0"/>
                         </a:rPr>
-                        <a:t>[Tecnología]</a:t>
+                        <a:t>Android (Java) + SOAP por HTTP</a:t>
                       </a:r>
                     </a:p>
                   </a:txBody>
@@ -18684,7 +19900,7 @@
                           </a:solidFill>
                           <a:latin typeface="Segoe UI" panose="020B0502040204020203" pitchFamily="34" charset="0"/>
                         </a:rPr>
-                        <a:t>[x.y]</a:t>
+                        <a:t>Android SDK 36 · Java 17</a:t>
                       </a:r>
                     </a:p>
                   </a:txBody>
@@ -18755,7 +19971,7 @@
                           </a:solidFill>
                           <a:latin typeface="Segoe UI" panose="020B0502040204020203" pitchFamily="34" charset="0"/>
                         </a:rPr>
-                        <a:t>[IDE, gestor de paquetes, emulador]</a:t>
+                        <a:t>NetBeans 31, Maven, Gradle, emulador Android</a:t>
                       </a:r>
                     </a:p>
                   </a:txBody>
@@ -18787,7 +20003,7 @@
                           </a:solidFill>
                           <a:latin typeface="Segoe UI" panose="020B0502040204020203" pitchFamily="34" charset="0"/>
                         </a:rPr>
-                        <a:t>[x.y]</a:t>
+                        <a:t>NetBeans 31</a:t>
                       </a:r>
                     </a:p>
                   </a:txBody>
@@ -19012,7 +20228,7 @@
                 </a:solidFill>
                 <a:latin typeface="Segoe UI Semibold" panose="020B0702040204020203" pitchFamily="34" charset="0"/>
               </a:rPr>
-              <a:t>Servidor [SOAP | RESTful]</a:t>
+              <a:t>Servidor SOAP</a:t>
             </a:r>
           </a:p>
           <a:p>
@@ -19028,7 +20244,7 @@
                 </a:solidFill>
                 <a:latin typeface="Segoe UI" panose="020B0502040204020203" pitchFamily="34" charset="0"/>
               </a:rPr>
-              <a:t>[JAVA | .NET] · [localhost:puerto]</a:t>
+              <a:t>JAVA · localhost:8080</a:t>
             </a:r>
           </a:p>
           <a:p>
@@ -19132,7 +20348,7 @@
                 </a:solidFill>
                 <a:latin typeface="Segoe UI" panose="020B0502040204020203" pitchFamily="34" charset="0"/>
               </a:rPr>
-              <a:t>[Tecnología]</a:t>
+              <a:t>Java + Apache CXF</a:t>
             </a:r>
           </a:p>
         </p:txBody>
@@ -19263,7 +20479,7 @@
                 </a:solidFill>
                 <a:latin typeface="Segoe UI" panose="020B0502040204020203" pitchFamily="34" charset="0"/>
               </a:rPr>
-              <a:t>[Tecnología]</a:t>
+              <a:t>Java Swing</a:t>
             </a:r>
           </a:p>
         </p:txBody>
@@ -19394,7 +20610,7 @@
                 </a:solidFill>
                 <a:latin typeface="Segoe UI" panose="020B0502040204020203" pitchFamily="34" charset="0"/>
               </a:rPr>
-              <a:t>[Tecnología]</a:t>
+              <a:t>JSP / Servlets</a:t>
             </a:r>
           </a:p>
         </p:txBody>
@@ -19525,7 +20741,7 @@
                 </a:solidFill>
                 <a:latin typeface="Segoe UI" panose="020B0502040204020203" pitchFamily="34" charset="0"/>
               </a:rPr>
-              <a:t>[Tecnología]</a:t>
+              <a:t>Android (Java)</a:t>
             </a:r>
           </a:p>
         </p:txBody>
@@ -19609,7 +20825,7 @@
                 </a:solidFill>
                 <a:latin typeface="Segoe UI" panose="020B0502040204020203" pitchFamily="34" charset="0"/>
               </a:rPr>
-              <a:t>Comunicación: [mensajes SOAP en XML | HTTP con JSON] · autenticación por token en cada llamada</a:t>
+              <a:t>Comunicación: mensajes SOAP en XML · autenticación por token en cada llamada</a:t>
             </a:r>
             <a:endParaRPr lang="es-EC" sz="1400">
               <a:solidFill>

</xml_diff>